<commit_message>
Fix PPTX skills overflow; add Tableau + honest star ratings
Shrink/trim the technical-skills box so it no longer overlaps the brief-
summary section; add Tableau to Key Skills; add honest star ratings
(SQL 5, Python 4, Tableau 4, Databricks 2 - internship-level).

Co-Authored-By: Claude Opus 4.8 <noreply@anthropic.com>
Claude-Session: https://claude.ai/code/session_01TuhM6r1rkWffWN6sdrTeQ9
</commit_message>
<xml_diff>
--- a/job-search/pipeline/infosys-consulting--data-engineer/Dhruv_Nirmal.pptx
+++ b/job-search/pipeline/infosys-consulting--data-engineer/Dhruv_Nirmal.pptx
@@ -22164,8 +22164,8 @@
         </p:nvSpPr>
         <p:spPr bwMode="auto">
           <a:xfrm>
-            <a:off x="162708" y="1808629"/>
-            <a:ext cx="1581447" cy="836981"/>
+            <a:off x="164592" y="1810512"/>
+            <a:ext cx="2331720" cy="841248"/>
           </a:xfrm>
           <a:prstGeom prst="rect">
             <a:avLst/>
@@ -22180,68 +22180,179 @@
           <a:effectLst/>
         </p:spPr>
         <p:txBody>
-          <a:bodyPr wrap="square" lIns="97367" tIns="48683" rIns="97367" bIns="48683">
+          <a:bodyPr wrap="square" lIns="36576" tIns="18288" rIns="18288" bIns="9144">
             <a:spAutoFit/>
           </a:bodyPr>
           <a:lstStyle/>
           <a:p>
             <a:pPr defTabSz="781031" eaLnBrk="0" hangingPunct="0">
+              <a:lnSpc>
+                <a:spcPct val="98000"/>
+              </a:lnSpc>
+              <a:spcAft>
+                <a:spcPts val="100"/>
+              </a:spcAft>
               <a:defRPr/>
             </a:pPr>
             <a:r>
-              <a:rPr lang="en-US" sz="1200" b="1" kern="0" dirty="0">
+              <a:rPr sz="1100" b="1">
                 <a:solidFill>
-                  <a:srgbClr val="000000"/>
+                  <a:srgbClr val="222222"/>
                 </a:solidFill>
-                <a:latin typeface="Arial Nova" panose="020B0504020202020204" pitchFamily="34" charset="0"/>
-                <a:cs typeface="Arial" panose="020B0604020202020204" pitchFamily="34" charset="0"/>
+                <a:latin typeface="Arial Nova"/>
               </a:rPr>
               <a:t>Key Skills</a:t>
             </a:r>
           </a:p>
           <a:p>
-            <a:pPr defTabSz="781031" eaLnBrk="0" hangingPunct="0">
-              <a:defRPr/>
+            <a:pPr>
+              <a:lnSpc>
+                <a:spcPct val="98000"/>
+              </a:lnSpc>
+              <a:spcBef>
+                <a:spcPts val="0"/>
+              </a:spcBef>
+              <a:spcAft>
+                <a:spcPts val="0"/>
+              </a:spcAft>
             </a:pPr>
             <a:r>
-              <a:rPr lang="en-US" sz="1200" kern="0" dirty="0">
+              <a:rPr sz="950" b="0">
                 <a:solidFill>
-                  <a:srgbClr val="000000"/>
+                  <a:srgbClr val="222222"/>
                 </a:solidFill>
-                <a:latin typeface="Arial Nova" panose="020B0504020202020204" pitchFamily="34" charset="0"/>
-                <a:cs typeface="Arial" panose="020B0604020202020204" pitchFamily="34" charset="0"/>
+                <a:latin typeface="Arial Nova"/>
               </a:rPr>
-              <a:t>Python</a:t>
+              <a:t>Advanced SQL  </a:t>
+            </a:r>
+            <a:r>
+              <a:rPr sz="950">
+                <a:solidFill>
+                  <a:srgbClr val="E8A000"/>
+                </a:solidFill>
+                <a:latin typeface="Arial Nova"/>
+              </a:rPr>
+              <a:t>★★★★★</a:t>
             </a:r>
           </a:p>
           <a:p>
-            <a:pPr defTabSz="781031" eaLnBrk="0" hangingPunct="0">
-              <a:defRPr/>
+            <a:pPr>
+              <a:lnSpc>
+                <a:spcPct val="98000"/>
+              </a:lnSpc>
+              <a:spcBef>
+                <a:spcPts val="0"/>
+              </a:spcBef>
+              <a:spcAft>
+                <a:spcPts val="0"/>
+              </a:spcAft>
             </a:pPr>
             <a:r>
-              <a:rPr lang="en-US" sz="1200" kern="0" dirty="0">
+              <a:rPr sz="950" b="0">
                 <a:solidFill>
-                  <a:srgbClr val="000000"/>
+                  <a:srgbClr val="222222"/>
                 </a:solidFill>
-                <a:latin typeface="Arial Nova" panose="020B0504020202020204" pitchFamily="34" charset="0"/>
-                <a:cs typeface="Arial" panose="020B0604020202020204" pitchFamily="34" charset="0"/>
+                <a:latin typeface="Arial Nova"/>
               </a:rPr>
-              <a:t>SQL</a:t>
+              <a:t>Python  </a:t>
+            </a:r>
+            <a:r>
+              <a:rPr sz="950">
+                <a:solidFill>
+                  <a:srgbClr val="E8A000"/>
+                </a:solidFill>
+                <a:latin typeface="Arial Nova"/>
+              </a:rPr>
+              <a:t>★★★★</a:t>
+            </a:r>
+            <a:r>
+              <a:rPr sz="950">
+                <a:solidFill>
+                  <a:srgbClr val="C2C8D0"/>
+                </a:solidFill>
+                <a:latin typeface="Arial Nova"/>
+              </a:rPr>
+              <a:t>☆</a:t>
             </a:r>
           </a:p>
           <a:p>
-            <a:pPr defTabSz="781031" eaLnBrk="0" hangingPunct="0">
-              <a:defRPr/>
+            <a:pPr>
+              <a:lnSpc>
+                <a:spcPct val="98000"/>
+              </a:lnSpc>
+              <a:spcBef>
+                <a:spcPts val="0"/>
+              </a:spcBef>
+              <a:spcAft>
+                <a:spcPts val="0"/>
+              </a:spcAft>
             </a:pPr>
             <a:r>
-              <a:rPr lang="en-US" sz="1200" kern="0" dirty="0">
+              <a:rPr sz="950" b="0">
                 <a:solidFill>
-                  <a:srgbClr val="000000"/>
+                  <a:srgbClr val="222222"/>
                 </a:solidFill>
-                <a:latin typeface="Arial Nova" panose="020B0504020202020204" pitchFamily="34" charset="0"/>
-                <a:cs typeface="Arial" panose="020B0604020202020204" pitchFamily="34" charset="0"/>
+                <a:latin typeface="Arial Nova"/>
               </a:rPr>
-              <a:t>Databricks</a:t>
+              <a:t>Tableau  </a:t>
+            </a:r>
+            <a:r>
+              <a:rPr sz="950">
+                <a:solidFill>
+                  <a:srgbClr val="E8A000"/>
+                </a:solidFill>
+                <a:latin typeface="Arial Nova"/>
+              </a:rPr>
+              <a:t>★★★★</a:t>
+            </a:r>
+            <a:r>
+              <a:rPr sz="950">
+                <a:solidFill>
+                  <a:srgbClr val="C2C8D0"/>
+                </a:solidFill>
+                <a:latin typeface="Arial Nova"/>
+              </a:rPr>
+              <a:t>☆</a:t>
+            </a:r>
+          </a:p>
+          <a:p>
+            <a:pPr>
+              <a:lnSpc>
+                <a:spcPct val="98000"/>
+              </a:lnSpc>
+              <a:spcBef>
+                <a:spcPts val="0"/>
+              </a:spcBef>
+              <a:spcAft>
+                <a:spcPts val="0"/>
+              </a:spcAft>
+            </a:pPr>
+            <a:r>
+              <a:rPr sz="950" b="0">
+                <a:solidFill>
+                  <a:srgbClr val="222222"/>
+                </a:solidFill>
+                <a:latin typeface="Arial Nova"/>
+              </a:rPr>
+              <a:t>Databricks  </a:t>
+            </a:r>
+            <a:r>
+              <a:rPr sz="950">
+                <a:solidFill>
+                  <a:srgbClr val="E8A000"/>
+                </a:solidFill>
+                <a:latin typeface="Arial Nova"/>
+              </a:rPr>
+              <a:t>★★</a:t>
+            </a:r>
+            <a:r>
+              <a:rPr sz="950">
+                <a:solidFill>
+                  <a:srgbClr val="C2C8D0"/>
+                </a:solidFill>
+                <a:latin typeface="Arial Nova"/>
+              </a:rPr>
+              <a:t>☆☆☆</a:t>
             </a:r>
           </a:p>
         </p:txBody>
@@ -22967,8 +23078,8 @@
         </p:nvSpPr>
         <p:spPr>
           <a:xfrm>
-            <a:off x="5037473" y="795821"/>
-            <a:ext cx="6974112" cy="1708160"/>
+            <a:off x="5038344" y="731520"/>
+            <a:ext cx="6976872" cy="1874519"/>
           </a:xfrm>
           <a:prstGeom prst="rect">
             <a:avLst/>
@@ -22976,14 +23087,24 @@
           <a:noFill/>
         </p:spPr>
         <p:txBody>
-          <a:bodyPr wrap="square">
+          <a:bodyPr wrap="square" tIns="18288" bIns="18288" lIns="45720" rIns="45720">
             <a:spAutoFit/>
           </a:bodyPr>
           <a:lstStyle/>
           <a:p>
-            <a:pPr algn="just"/>
+            <a:pPr algn="just">
+              <a:lnSpc>
+                <a:spcPct val="94000"/>
+              </a:lnSpc>
+              <a:spcBef>
+                <a:spcPts val="0"/>
+              </a:spcBef>
+              <a:spcAft>
+                <a:spcPts val="100"/>
+              </a:spcAft>
+            </a:pPr>
             <a:r>
-              <a:rPr lang="en-US" sz="1050" b="1" dirty="0">
+              <a:rPr lang="en-US" sz="900" b="1" dirty="0">
                 <a:latin typeface="Arial Nova" panose="020B0504020202020204" pitchFamily="34" charset="0"/>
               </a:rPr>
               <a:t>Functional Skills:</a:t>
@@ -22993,18 +23114,38 @@
             </a:endParaRPr>
           </a:p>
           <a:p>
-            <a:pPr algn="just"/>
+            <a:pPr algn="just">
+              <a:lnSpc>
+                <a:spcPct val="94000"/>
+              </a:lnSpc>
+              <a:spcBef>
+                <a:spcPts val="0"/>
+              </a:spcBef>
+              <a:spcAft>
+                <a:spcPts val="100"/>
+              </a:spcAft>
+            </a:pPr>
             <a:r>
-              <a:rPr lang="en-US" sz="1050" dirty="0">
+              <a:rPr lang="en-US" sz="900" dirty="0">
                 <a:latin typeface="Arial Nova" panose="020B0504020202020204" pitchFamily="34" charset="0"/>
               </a:rPr>
-              <a:t>Data Pipeline Design, Requirements Gathering, Stakeholder Management, Cross-Functional Collaboration, Process Automation, Data Quality Assurance, Data Storytelling, Client Delivery</a:t>
+              <a:t>Data Pipeline Design, Requirements Gathering, Stakeholder Management, Process Automation, Data Quality Assurance, Client Delivery</a:t>
             </a:r>
           </a:p>
           <a:p>
-            <a:pPr algn="just"/>
+            <a:pPr algn="just">
+              <a:lnSpc>
+                <a:spcPct val="94000"/>
+              </a:lnSpc>
+              <a:spcBef>
+                <a:spcPts val="0"/>
+              </a:spcBef>
+              <a:spcAft>
+                <a:spcPts val="100"/>
+              </a:spcAft>
+            </a:pPr>
             <a:r>
-              <a:rPr lang="en-US" sz="1050" b="1" dirty="0">
+              <a:rPr lang="en-US" sz="900" b="1" dirty="0">
                 <a:latin typeface="Arial Nova" panose="020B0504020202020204" pitchFamily="34" charset="0"/>
               </a:rPr>
               <a:t>Technical Skills:</a:t>
@@ -23014,87 +23155,137 @@
             </a:endParaRPr>
           </a:p>
           <a:p>
-            <a:pPr algn="just"/>
+            <a:pPr algn="just">
+              <a:lnSpc>
+                <a:spcPct val="94000"/>
+              </a:lnSpc>
+              <a:spcBef>
+                <a:spcPts val="0"/>
+              </a:spcBef>
+              <a:spcAft>
+                <a:spcPts val="100"/>
+              </a:spcAft>
+            </a:pPr>
             <a:r>
-              <a:rPr lang="en-US" sz="1050" b="1" dirty="0">
+              <a:rPr lang="en-US" sz="900" b="1" dirty="0">
                 <a:latin typeface="Arial Nova" panose="020B0504020202020204" pitchFamily="34" charset="0"/>
               </a:rPr>
               <a:t>Languages &amp; Pipelines: </a:t>
             </a:r>
             <a:r>
-              <a:rPr lang="en-US" sz="1050" dirty="0">
+              <a:rPr lang="en-US" sz="900" dirty="0">
                 <a:latin typeface="Arial Nova" panose="020B0504020202020204" pitchFamily="34" charset="0"/>
               </a:rPr>
-              <a:t>Python (Pandas, NumPy), Advanced SQL, ETL Pipeline Design, Full &amp; Incremental Refresh, Batch Automation, Data Modelling</a:t>
+              <a:t>Python (Pandas, NumPy), Advanced SQL, ETL Design, Full &amp; Incremental Refresh, Batch Automation</a:t>
             </a:r>
             <a:r>
-              <a:rPr lang="en-US" sz="1050" dirty="0" err="1">
+              <a:rPr lang="en-US" sz="900" dirty="0" err="1">
                 <a:latin typeface="Arial Nova" panose="020B0504020202020204" pitchFamily="34" charset="0"/>
               </a:rPr>
               <a:t/>
             </a:r>
             <a:r>
-              <a:rPr lang="en-US" sz="1050" dirty="0">
+              <a:rPr lang="en-US" sz="900" dirty="0">
                 <a:latin typeface="Arial Nova" panose="020B0504020202020204" pitchFamily="34" charset="0"/>
               </a:rPr>
               <a:t/>
             </a:r>
           </a:p>
           <a:p>
-            <a:pPr algn="just"/>
+            <a:pPr algn="just">
+              <a:lnSpc>
+                <a:spcPct val="94000"/>
+              </a:lnSpc>
+              <a:spcBef>
+                <a:spcPts val="0"/>
+              </a:spcBef>
+              <a:spcAft>
+                <a:spcPts val="100"/>
+              </a:spcAft>
+            </a:pPr>
             <a:r>
-              <a:rPr lang="en-US" sz="1050" b="1" dirty="0">
+              <a:rPr lang="en-US" sz="900" b="1" dirty="0">
                 <a:latin typeface="Arial Nova" panose="020B0504020202020204" pitchFamily="34" charset="0"/>
               </a:rPr>
               <a:t>Big Data &amp; Distributed</a:t>
             </a:r>
             <a:r>
-              <a:rPr lang="en-US" sz="1050" dirty="0">
+              <a:rPr lang="en-US" sz="900" dirty="0">
                 <a:latin typeface="Arial Nova" panose="020B0504020202020204" pitchFamily="34" charset="0"/>
               </a:rPr>
               <a:t>: Databricks, PySpark, Snowflake, KNIME</a:t>
             </a:r>
           </a:p>
           <a:p>
-            <a:pPr algn="just"/>
+            <a:pPr algn="just">
+              <a:lnSpc>
+                <a:spcPct val="94000"/>
+              </a:lnSpc>
+              <a:spcBef>
+                <a:spcPts val="0"/>
+              </a:spcBef>
+              <a:spcAft>
+                <a:spcPts val="100"/>
+              </a:spcAft>
+            </a:pPr>
             <a:r>
-              <a:rPr lang="en-US" sz="1050" b="1" dirty="0">
+              <a:rPr lang="en-US" sz="900" b="1" dirty="0">
                 <a:latin typeface="Arial Nova" panose="020B0504020202020204" pitchFamily="34" charset="0"/>
               </a:rPr>
               <a:t>Cloud &amp; Orchestration: </a:t>
             </a:r>
             <a:r>
-              <a:rPr lang="en-US" sz="1050" dirty="0">
+              <a:rPr lang="en-US" sz="900" dirty="0">
                 <a:latin typeface="Arial Nova" panose="020B0504020202020204" pitchFamily="34" charset="0"/>
               </a:rPr>
-              <a:t>Azure (Microsoft Graph API), AWS (S3, EC2, IAM, Lambda, Glue), Terraform (IaC), Docker, Windows Task Scheduler</a:t>
+              <a:t>Azure (Graph API), AWS (S3, EC2, IAM, Lambda, Glue), Terraform, Docker</a:t>
             </a:r>
           </a:p>
           <a:p>
-            <a:pPr algn="just"/>
+            <a:pPr algn="just">
+              <a:lnSpc>
+                <a:spcPct val="94000"/>
+              </a:lnSpc>
+              <a:spcBef>
+                <a:spcPts val="0"/>
+              </a:spcBef>
+              <a:spcAft>
+                <a:spcPts val="100"/>
+              </a:spcAft>
+            </a:pPr>
             <a:r>
-              <a:rPr lang="en-US" sz="1050" b="1" dirty="0">
+              <a:rPr lang="en-US" sz="900" b="1" dirty="0">
                 <a:latin typeface="Arial Nova" panose="020B0504020202020204" pitchFamily="34" charset="0"/>
               </a:rPr>
               <a:t>Version Control &amp; Data Quality: </a:t>
             </a:r>
             <a:r>
-              <a:rPr lang="en-US" sz="1050" dirty="0">
+              <a:rPr lang="en-US" sz="900" dirty="0">
                 <a:latin typeface="Arial Nova" panose="020B0504020202020204" pitchFamily="34" charset="0"/>
               </a:rPr>
-              <a:t>Git, Automated Validation, Anomaly Detection, Reproducible &amp; Documented Pipelines</a:t>
+              <a:t>Git, Automated Validation, Reproducible Pipelines</a:t>
             </a:r>
           </a:p>
           <a:p>
-            <a:pPr algn="just"/>
+            <a:pPr algn="just">
+              <a:lnSpc>
+                <a:spcPct val="94000"/>
+              </a:lnSpc>
+              <a:spcBef>
+                <a:spcPts val="0"/>
+              </a:spcBef>
+              <a:spcAft>
+                <a:spcPts val="100"/>
+              </a:spcAft>
+            </a:pPr>
             <a:r>
-              <a:rPr lang="en-US" sz="1050" b="1" dirty="0">
+              <a:rPr lang="en-US" sz="900" b="1" dirty="0">
                 <a:latin typeface="Arial Nova" panose="020B0504020202020204" pitchFamily="34" charset="0"/>
               </a:rPr>
               <a:t>BI &amp; Reporting: </a:t>
             </a:r>
             <a:r>
-              <a:rPr lang="en-US" sz="1050" dirty="0">
+              <a:rPr lang="en-US" sz="900" dirty="0">
                 <a:latin typeface="Arial Nova" panose="020B0504020202020204" pitchFamily="34" charset="0"/>
               </a:rPr>
               <a:t>Power BI, Tableau, Dashboard Design, KPI Reporting</a:t>

</xml_diff>

<commit_message>
Key Skills: Tableau to 5 stars, remove Databricks from rated skills
Show only strengths (SQL 5, Python 4, Tableau 5) in the starred Key Skills
box; Databricks remains in the technical-skills list, unrated.

Co-Authored-By: Claude Opus 4.8 <noreply@anthropic.com>
Claude-Session: https://claude.ai/code/session_01TuhM6r1rkWffWN6sdrTeQ9
</commit_message>
<xml_diff>
--- a/job-search/pipeline/infosys-consulting--data-engineer/Dhruv_Nirmal.pptx
+++ b/job-search/pipeline/infosys-consulting--data-engineer/Dhruv_Nirmal.pptx
@@ -22303,56 +22303,7 @@
                 </a:solidFill>
                 <a:latin typeface="Arial Nova"/>
               </a:rPr>
-              <a:t>★★★★</a:t>
-            </a:r>
-            <a:r>
-              <a:rPr sz="950">
-                <a:solidFill>
-                  <a:srgbClr val="C2C8D0"/>
-                </a:solidFill>
-                <a:latin typeface="Arial Nova"/>
-              </a:rPr>
-              <a:t>☆</a:t>
-            </a:r>
-          </a:p>
-          <a:p>
-            <a:pPr>
-              <a:lnSpc>
-                <a:spcPct val="98000"/>
-              </a:lnSpc>
-              <a:spcBef>
-                <a:spcPts val="0"/>
-              </a:spcBef>
-              <a:spcAft>
-                <a:spcPts val="0"/>
-              </a:spcAft>
-            </a:pPr>
-            <a:r>
-              <a:rPr sz="950" b="0">
-                <a:solidFill>
-                  <a:srgbClr val="222222"/>
-                </a:solidFill>
-                <a:latin typeface="Arial Nova"/>
-              </a:rPr>
-              <a:t>Databricks  </a:t>
-            </a:r>
-            <a:r>
-              <a:rPr sz="950">
-                <a:solidFill>
-                  <a:srgbClr val="E8A000"/>
-                </a:solidFill>
-                <a:latin typeface="Arial Nova"/>
-              </a:rPr>
-              <a:t>★★</a:t>
-            </a:r>
-            <a:r>
-              <a:rPr sz="950">
-                <a:solidFill>
-                  <a:srgbClr val="C2C8D0"/>
-                </a:solidFill>
-                <a:latin typeface="Arial Nova"/>
-              </a:rPr>
-              <a:t>☆☆☆</a:t>
+              <a:t>★★★★★</a:t>
             </a:r>
           </a:p>
         </p:txBody>

</xml_diff>

<commit_message>
Differentiate the two PPTX experience sections
Professional Background is now a career/context narrative (employer, scope,
stack, arc); the achievement bullets with numbers live only in the right-hand
Roles & Responsibilities. Removes the near-duplicate content.

Co-Authored-By: Claude Opus 4.8 <noreply@anthropic.com>
Claude-Session: https://claude.ai/code/session_01TuhM6r1rkWffWN6sdrTeQ9
</commit_message>
<xml_diff>
--- a/job-search/pipeline/infosys-consulting--data-engineer/Dhruv_Nirmal.pptx
+++ b/job-search/pipeline/infosys-consulting--data-engineer/Dhruv_Nirmal.pptx
@@ -21591,7 +21591,7 @@
                 <a:latin typeface="Arial Nova" panose="020B0504020202020204" pitchFamily="34" charset="0"/>
                 <a:cs typeface="Arial" panose="020B0604020202020204" pitchFamily="34" charset="0"/>
               </a:rPr>
-              <a:t>Experienced Data Engineer focused on building automated, reliable data pipelines and turning messy enterprise data into trusted analytics across multiple clients in a consulting environment. Skilled in end-to-end ETL, data validation, incremental refresh, and BI delivery. </a:t>
+              <a:t>Delivers reliable, automated pipelines and trusted analytics for enterprise clients, with a focus on speed, data quality and reproducibility. </a:t>
             </a:r>
             <a:br>
               <a:rPr lang="en-US" sz="1100" dirty="0">
@@ -23277,7 +23277,7 @@
               <a:rPr lang="en-US" sz="1050" b="1" dirty="0">
                 <a:latin typeface="Arial Nova" panose="020B0504020202020204" pitchFamily="34" charset="0"/>
               </a:rPr>
-              <a:t>Professional Experience:</a:t>
+              <a:t>Data Engineer, Purchasing Index Data Analytics (Comprara Group)</a:t>
             </a:r>
           </a:p>
           <a:p>
@@ -23292,16 +23292,16 @@
               <a:buChar char="•"/>
             </a:pPr>
             <a:r>
-              <a:rPr lang="en-US" sz="1050" b="1" dirty="0">
+              <a:rPr lang="en-US" sz="1050" b="0" dirty="0">
                 <a:latin typeface="Arial Nova" panose="020B0504020202020204" pitchFamily="34" charset="0"/>
               </a:rPr>
-              <a:t>Data Engineer, PI Data Analytics (Comprara Group)</a:t>
+              <a:t>A Melbourne data and analytics consultancy serving enterprise clients across Australia and New Zealand. Owns client data pipelines end to end, from ingestion through validation and transformation to reporting.</a:t>
             </a:r>
             <a:r>
               <a:rPr lang="en-US" sz="1050" dirty="0">
                 <a:latin typeface="Arial Nova" panose="020B0504020202020204" pitchFamily="34" charset="0"/>
               </a:rPr>
-              <a:t>: Own end-to-end pipelines for five enterprise clients - ingestion, validation, transformation and delivery - building and maintaining 20+ automated ETL pipelines in Python and advanced SQL.</a:t>
+              <a:t/>
             </a:r>
           </a:p>
           <a:p>
@@ -23310,23 +23310,62 @@
               <a:buChar char="•"/>
             </a:pPr>
             <a:r>
-              <a:rPr lang="en-US" sz="1050" b="1" dirty="0">
+              <a:rPr lang="en-US" sz="1050" b="0" dirty="0">
                 <a:latin typeface="Arial Nova" panose="020B0504020202020204" pitchFamily="34" charset="0"/>
               </a:rPr>
-              <a:t>Flagship Pipeline</a:t>
+              <a:t>Runs delivery for five enterprise clients and has built and maintained 20+ automated ETL pipelines in Python and advanced SQL, cutting manual reporting effort by around 40% and turnaround by around 50%.</a:t>
             </a:r>
             <a:r>
               <a:rPr lang="en-US" sz="1050" dirty="0">
                 <a:latin typeface="Arial Nova" panose="020B0504020202020204" pitchFamily="34" charset="0"/>
               </a:rPr>
-              <a:t>: </a:t>
+              <a:t/>
             </a:r>
             <a:r>
               <a:rPr lang="en-US" sz="1050" dirty="0">
                 <a:latin typeface="Arial" panose="020B0604020202020204" pitchFamily="34" charset="0"/>
                 <a:cs typeface="Arial" panose="020B0604020202020204" pitchFamily="34" charset="0"/>
               </a:rPr>
-              <a:t>Replaced a 4-5 hour manual weekly process with a ~75-minute automated run over ~6 million invoice rows across 5 regions, via Microsoft Graph API ingestion and automated validation.</a:t>
+              <a:t/>
+            </a:r>
+          </a:p>
+          <a:p>
+            <a:pPr algn="just">
+              <a:buFont typeface="Arial" panose="020B0604020202020204" pitchFamily="34" charset="0"/>
+              <a:buChar char="•"/>
+            </a:pPr>
+            <a:r>
+              <a:rPr lang="en-US" sz="1050" dirty="0" b="0">
+                <a:latin typeface="Arial" panose="020B0604020202020204" pitchFamily="34" charset="0"/>
+                <a:cs typeface="Arial" panose="020B0604020202020204" pitchFamily="34" charset="0"/>
+              </a:rPr>
+              <a:t>Builds automated validation, idempotent incremental refresh and version control (Git) into every pipeline, turning slow, manual processes into fast, reliable, one-click runs.</a:t>
+            </a:r>
+          </a:p>
+          <a:p>
+            <a:pPr algn="just">
+              <a:buFont typeface="Arial" panose="020B0604020202020204" pitchFamily="34" charset="0"/>
+              <a:buChar char="•"/>
+            </a:pPr>
+            <a:r>
+              <a:rPr lang="en-US" sz="1050" dirty="0" b="0">
+                <a:latin typeface="Arial" panose="020B0604020202020204" pitchFamily="34" charset="0"/>
+                <a:cs typeface="Arial" panose="020B0604020202020204" pitchFamily="34" charset="0"/>
+              </a:rPr>
+              <a:t>Works across the modern data stack: Python and advanced SQL day to day, distributed processing with Databricks and PySpark, cloud on Azure and AWS, and reporting in Power BI and Tableau.</a:t>
+            </a:r>
+          </a:p>
+          <a:p>
+            <a:pPr algn="just">
+              <a:buFont typeface="Arial" panose="020B0604020202020204" pitchFamily="34" charset="0"/>
+              <a:buChar char="•"/>
+            </a:pPr>
+            <a:r>
+              <a:rPr lang="en-US" sz="1050" dirty="0" b="0">
+                <a:latin typeface="Arial" panose="020B0604020202020204" pitchFamily="34" charset="0"/>
+                <a:cs typeface="Arial" panose="020B0604020202020204" pitchFamily="34" charset="0"/>
+              </a:rPr>
+              <a:t>Started out in distributed data engineering during an internship at the Victorian Centre for Data Insights, delivering a PySpark pipeline on Databricks.</a:t>
             </a:r>
           </a:p>
           <a:p>
@@ -23339,7 +23378,7 @@
                 <a:latin typeface="Arial" panose="020B0604020202020204" pitchFamily="34" charset="0"/>
                 <a:cs typeface="Arial" panose="020B0604020202020204" pitchFamily="34" charset="0"/>
               </a:rPr>
-              <a:t>Leading a company-wide self-service app that turns each client refresh into one click across all 26 accounts, with full and incremental runs, maintained end to end in Git.</a:t>
+              <a:t/>
             </a:r>
           </a:p>
           <a:p>
@@ -23352,46 +23391,7 @@
                 <a:latin typeface="Arial" panose="020B0604020202020204" pitchFamily="34" charset="0"/>
                 <a:cs typeface="Arial" panose="020B0604020202020204" pitchFamily="34" charset="0"/>
               </a:rPr>
-              <a:t>Built a Python and scikit-learn classifier over a ~A$12B spend book, cutting a month of manual categorisation to a single day's run, then reused across client accounts.</a:t>
-            </a:r>
-          </a:p>
-          <a:p>
-            <a:pPr algn="just">
-              <a:buFont typeface="Arial" panose="020B0604020202020204" pitchFamily="34" charset="0"/>
-              <a:buChar char="•"/>
-            </a:pPr>
-            <a:r>
-              <a:rPr lang="en-US" sz="1050" dirty="0">
-                <a:latin typeface="Arial" panose="020B0604020202020204" pitchFamily="34" charset="0"/>
-                <a:cs typeface="Arial" panose="020B0604020202020204" pitchFamily="34" charset="0"/>
-              </a:rPr>
-              <a:t>Built a distributed anomaly-detection pipeline in Databricks with PySpark during an internship (VCDI), improving detection accuracy by ~20%.</a:t>
-            </a:r>
-          </a:p>
-          <a:p>
-            <a:pPr algn="just">
-              <a:buFont typeface="Arial" panose="020B0604020202020204" pitchFamily="34" charset="0"/>
-              <a:buChar char="•"/>
-            </a:pPr>
-            <a:r>
-              <a:rPr lang="en-US" sz="1050" dirty="0">
-                <a:latin typeface="Arial" panose="020B0604020202020204" pitchFamily="34" charset="0"/>
-                <a:cs typeface="Arial" panose="020B0604020202020204" pitchFamily="34" charset="0"/>
-              </a:rPr>
-              <a:t>Design idempotent, incremental-refresh pipelines with automated validation - row, type and column checks - and failure alerting for safe re-runs.</a:t>
-            </a:r>
-          </a:p>
-          <a:p>
-            <a:pPr algn="just">
-              <a:buFont typeface="Arial" panose="020B0604020202020204" pitchFamily="34" charset="0"/>
-              <a:buChar char="•"/>
-            </a:pPr>
-            <a:r>
-              <a:rPr lang="en-US" sz="1050" dirty="0">
-                <a:latin typeface="Arial" panose="020B0604020202020204" pitchFamily="34" charset="0"/>
-                <a:cs typeface="Arial" panose="020B0604020202020204" pitchFamily="34" charset="0"/>
-              </a:rPr>
-              <a:t>Built and maintained 16+ Tableau dashboards and a Power BI solution giving procurement and finance stakeholders live visibility into spend and KPIs.</a:t>
+              <a:t/>
             </a:r>
           </a:p>
         </p:txBody>

</xml_diff>

<commit_message>
Confine Databricks/PySpark to internship context in both profiles
Remove Databricks/PySpark from current-role narrative (PPTX background line
and DOCX summary); mention them only as internship experience so the
hands-on-vs-current distinction is unambiguous.

Co-Authored-By: Claude Opus 4.8 <noreply@anthropic.com>
Claude-Session: https://claude.ai/code/session_01TuhM6r1rkWffWN6sdrTeQ9
</commit_message>
<xml_diff>
--- a/job-search/pipeline/infosys-consulting--data-engineer/Dhruv_Nirmal.pptx
+++ b/job-search/pipeline/infosys-consulting--data-engineer/Dhruv_Nirmal.pptx
@@ -21779,7 +21779,7 @@
                 <a:latin typeface="Arial Nova" panose="020B0504020202020204" pitchFamily="34" charset="0"/>
                 <a:cs typeface="Arial" panose="020B0604020202020204" pitchFamily="34" charset="0"/>
               </a:rPr>
-              <a:t>Built a distributed anomaly-detection pipeline in Databricks and PySpark, engineering scalable transformation layers and improving detection accuracy by ~20%.</a:t>
+              <a:t>During an internship at the Victorian Centre for Data Insights, built a distributed anomaly-detection pipeline in Databricks and PySpark, improving detection accuracy by ~20%.</a:t>
             </a:r>
           </a:p>
           <a:p>
@@ -23352,7 +23352,7 @@
                 <a:latin typeface="Arial" panose="020B0604020202020204" pitchFamily="34" charset="0"/>
                 <a:cs typeface="Arial" panose="020B0604020202020204" pitchFamily="34" charset="0"/>
               </a:rPr>
-              <a:t>Works across the modern data stack: Python and advanced SQL day to day, distributed processing with Databricks and PySpark, cloud on Azure and AWS, and reporting in Power BI and Tableau.</a:t>
+              <a:t>Works across the modern data stack: Python and advanced SQL day to day, cloud on Azure and AWS, and reporting in Power BI and Tableau.</a:t>
             </a:r>
           </a:p>
           <a:p>

</xml_diff>